<commit_message>
Add PPTX justified text layout slice
</commit_message>
<xml_diff>
--- a/tests/Lokad.OoxPdf.Tests/Cases/pptx-ladder-04-typography-justify-port.pptx
+++ b/tests/Lokad.OoxPdf.Tests/Cases/pptx-ladder-04-typography-justify-port.pptx
@@ -3356,7 +3356,7 @@
               <a:rPr sz="1800">
                 <a:latin typeface="Calibri"/>
               </a:rPr>
-              <a:t>Paragraph one aligned justify. Lorem ipsum dolor sit amet, consectetur adipiscing elit.</a:t>
+              <a:t>Paragraph one aligned justify. Lorem ipsum dolor sit amet, consectetur adipiscing elit, sed do eiusmod tempor incididunt ut labore et dolore magna aliqua.</a:t>
             </a:r>
           </a:p>
           <a:p>
@@ -3365,7 +3365,7 @@
               <a:rPr sz="1800">
                 <a:latin typeface="Calibri"/>
               </a:rPr>
-              <a:t>Paragraph two aligned justify. Demand planning text should distribute word spacing across wrapped lines.</a:t>
+              <a:t>Paragraph two aligned justify. Demand planning text should distribute word spacing across wrapped lines while preserving the final visual line.</a:t>
             </a:r>
           </a:p>
           <a:p>
@@ -3374,7 +3374,7 @@
               <a:rPr sz="1800">
                 <a:latin typeface="Calibri"/>
               </a:rPr>
-              <a:t>Paragraph three aligned justify. The last visual line should remain left aligned like PowerPoint.</a:t>
+              <a:t>Paragraph three aligned justify. The last visual line should remain left aligned like PowerPoint even when earlier lines expand spaces.</a:t>
             </a:r>
           </a:p>
         </p:txBody>

</xml_diff>